<commit_message>
fix(backend): update Recognition and Volunteers certificate templates
</commit_message>
<xml_diff>
--- a/backend/CERTIFICATE_TEMPLATE - Recognition .pptx
+++ b/backend/CERTIFICATE_TEMPLATE - Recognition .pptx
@@ -4572,7 +4572,43 @@
                 <a:cs typeface="Cardo" panose="02020600000000000000"/>
                 <a:sym typeface="Cardo" panose="02020600000000000000"/>
               </a:rPr>
-              <a:t>We sincerely appreciate your outstanding dedication, expertise, impartiality, and fair judgment demonstrated while serving as an official Judge for the {{EVENT NAME}}, organized by Trinity College of Engineering and Technology - Automation, Peddapalli, and held on {{DATE}}.</a:t>
+              <a:t>We sincerely appreciate your outstanding dedication, expertise, impartiality, and fair judgment demonstrated while serving as an official Judge for the {{EVENT NAME}}, organized by Trinity College of Engineering and Technology - </a:t>
+            </a:r>
+            <a:r>
+              <a:rPr lang="en-US" altLang="en-US" sz="1280">
+                <a:solidFill>
+                  <a:srgbClr val="0D1E4A"/>
+                </a:solidFill>
+                <a:latin typeface="Cardo" panose="02020600000000000000"/>
+                <a:ea typeface="Cardo" panose="02020600000000000000"/>
+                <a:cs typeface="Cardo" panose="02020600000000000000"/>
+                <a:sym typeface="Cardo" panose="02020600000000000000"/>
+              </a:rPr>
+              <a:t>Auto</a:t>
+            </a:r>
+            <a:r>
+              <a:rPr lang="en-IN" altLang="en-US" sz="1280">
+                <a:solidFill>
+                  <a:srgbClr val="0D1E4A"/>
+                </a:solidFill>
+                <a:latin typeface="Cardo" panose="02020600000000000000"/>
+                <a:ea typeface="Cardo" panose="02020600000000000000"/>
+                <a:cs typeface="Cardo" panose="02020600000000000000"/>
+                <a:sym typeface="Cardo" panose="02020600000000000000"/>
+              </a:rPr>
+              <a:t>nomous</a:t>
+            </a:r>
+            <a:r>
+              <a:rPr lang="en-US" altLang="en-US" sz="1280">
+                <a:solidFill>
+                  <a:srgbClr val="0D1E4A"/>
+                </a:solidFill>
+                <a:latin typeface="Cardo" panose="02020600000000000000"/>
+                <a:ea typeface="Cardo" panose="02020600000000000000"/>
+                <a:cs typeface="Cardo" panose="02020600000000000000"/>
+                <a:sym typeface="Cardo" panose="02020600000000000000"/>
+              </a:rPr>
+              <a:t>, Peddapalli, and held on {{DATE}}.</a:t>
             </a:r>
             <a:endParaRPr lang="en-US" altLang="en-US" sz="1280">
               <a:solidFill>

</xml_diff>